<commit_message>
fix: comprehensive template bleed removal across all 1000 pitch decks - remove a16z bleed from 380 investor-500 decks (dedicated AI fund, portfolio companies, adjacency text) - remove banking bleed from 49 investor-50 extra decks (Basel III, DORA, MiFID II) - remove banking bleed from 2 regional decks (121, 122) - fix slug-as-name display issues - regenerate 722 PDFs, sync all to public
</commit_message>
<xml_diff>
--- a/docs/pitch-decks/investor-100/pptx/018-menlo.pptx
+++ b/docs/pitch-decks/investor-100/pptx/018-menlo.pptx
@@ -2794,7 +2794,7 @@
                   <a:srgbClr val="8B8FA3"/>
                 </a:solidFill>
               </a:rPr>
-              <a:t>AI-first enterprise applications. Dedicated AI fund. Focus on foundational AI infrastructure and vertical AI.</a:t>
+              <a:t>Menlo Ventures invests in venture capital opportunities. Datacendia is the missing governance layer for enterprise AI.</a:t>
             </a:r>
             <a:endParaRPr lang="en-US" sz="1200" dirty="0"/>
           </a:p>
@@ -2895,7 +2895,7 @@
                   <a:srgbClr val="8B8FA3"/>
                 </a:solidFill>
               </a:rPr>
-              <a:t>Menlo's dedicated AI fund targets foundational infrastructure. Datacendia is foundational: the governance layer every enterprise AI deployment requires.</a:t>
+              <a:t>Menlo Ventures invests in venture capital opportunities. Datacendia is the missing governance layer for enterprise AI.</a:t>
             </a:r>
             <a:endParaRPr lang="en-US" sz="1100" dirty="0"/>
           </a:p>

</xml_diff>